<commit_message>
License update and quality checks
</commit_message>
<xml_diff>
--- a/dev-test-llm.pptx
+++ b/dev-test-llm.pptx
@@ -12,7 +12,7 @@
   </p:handoutMasterIdLst>
   <p:sldIdLst>
     <p:sldId id="5601" r:id="rId5"/>
-    <p:sldId id="320" r:id="rId6"/>
+    <p:sldId id="5695" r:id="rId6"/>
     <p:sldId id="5590" r:id="rId7"/>
     <p:sldId id="5577" r:id="rId8"/>
     <p:sldId id="5591" r:id="rId9"/>
@@ -334,7 +334,7 @@
           <a:p>
             <a:fld id="{0B842F42-2CE9-4E35-95C1-410DC08A50B1}" type="datetimeFigureOut">
               <a:rPr lang="en-US" smtClean="0"/>
-              <a:t>10/13/25</a:t>
+              <a:t>10/26/2025</a:t>
             </a:fld>
             <a:endParaRPr lang="en-US"/>
           </a:p>
@@ -499,7 +499,7 @@
           <a:p>
             <a:fld id="{6F282904-F315-4730-8D91-37D99E141A6F}" type="datetimeFigureOut">
               <a:rPr lang="en-US" smtClean="0"/>
-              <a:t>10/13/25</a:t>
+              <a:t>10/26/2025</a:t>
             </a:fld>
             <a:endParaRPr lang="en-US"/>
           </a:p>
@@ -4106,81 +4106,6 @@
       </p:grpSpPr>
       <p:sp>
         <p:nvSpPr>
-          <p:cNvPr id="2" name="Title 1"/>
-          <p:cNvSpPr>
-            <a:spLocks noGrp="1"/>
-          </p:cNvSpPr>
-          <p:nvPr>
-            <p:ph type="title" hasCustomPrompt="1"/>
-          </p:nvPr>
-        </p:nvSpPr>
-        <p:spPr/>
-        <p:txBody>
-          <a:bodyPr/>
-          <a:lstStyle>
-            <a:lvl1pPr marL="0" marR="0" indent="0" algn="l" defTabSz="914103" rtl="0" eaLnBrk="1" fontAlgn="auto" latinLnBrk="0" hangingPunct="1">
-              <a:lnSpc>
-                <a:spcPct val="90000"/>
-              </a:lnSpc>
-              <a:spcBef>
-                <a:spcPct val="0"/>
-              </a:spcBef>
-              <a:spcAft>
-                <a:spcPts val="0"/>
-              </a:spcAft>
-              <a:buClrTx/>
-              <a:buSzTx/>
-              <a:buFontTx/>
-              <a:buNone/>
-              <a:tabLst/>
-              <a:defRPr/>
-            </a:lvl1pPr>
-          </a:lstStyle>
-          <a:p>
-            <a:r>
-              <a:rPr lang="en-US" dirty="0"/>
-              <a:t>BASIC CONTENT SLIDE</a:t>
-            </a:r>
-            <a:br>
-              <a:rPr lang="en-US" dirty="0"/>
-            </a:br>
-            <a:r>
-              <a:rPr lang="en-US" dirty="0"/>
-              <a:t>one or two lines for headline</a:t>
-            </a:r>
-          </a:p>
-        </p:txBody>
-      </p:sp>
-      <p:sp>
-        <p:nvSpPr>
-          <p:cNvPr id="6" name="Slide Number Placeholder 5"/>
-          <p:cNvSpPr>
-            <a:spLocks noGrp="1"/>
-          </p:cNvSpPr>
-          <p:nvPr>
-            <p:ph type="sldNum" sz="quarter" idx="12"/>
-          </p:nvPr>
-        </p:nvSpPr>
-        <p:spPr/>
-        <p:txBody>
-          <a:bodyPr/>
-          <a:lstStyle>
-            <a:lvl1pPr>
-              <a:defRPr sz="1600"/>
-            </a:lvl1pPr>
-          </a:lstStyle>
-          <a:p>
-            <a:fld id="{9CF5EF28-261C-FD41-A360-1A380056DD17}" type="slidenum">
-              <a:rPr lang="en-US" smtClean="0"/>
-              <a:pPr/>
-              <a:t>‹#›</a:t>
-            </a:fld>
-            <a:endParaRPr lang="en-US" dirty="0"/>
-          </a:p>
-        </p:txBody>
-      </p:sp>
-      <p:sp>
-        <p:nvSpPr>
           <p:cNvPr id="16" name="Text Placeholder 15">
             <a:extLst>
               <a:ext uri="{FF2B5EF4-FFF2-40B4-BE49-F238E27FC236}">
@@ -4283,6 +4208,34 @@
             <a:r>
               <a:rPr lang="en-US" dirty="0"/>
               <a:t>Fifth level</a:t>
+            </a:r>
+          </a:p>
+        </p:txBody>
+      </p:sp>
+      <p:sp>
+        <p:nvSpPr>
+          <p:cNvPr id="3" name="Title 2">
+            <a:extLst>
+              <a:ext uri="{FF2B5EF4-FFF2-40B4-BE49-F238E27FC236}">
+                <a16:creationId xmlns:a16="http://schemas.microsoft.com/office/drawing/2014/main" id="{0822AC07-3824-1527-347C-F3420A0D9783}"/>
+              </a:ext>
+            </a:extLst>
+          </p:cNvPr>
+          <p:cNvSpPr>
+            <a:spLocks noGrp="1"/>
+          </p:cNvSpPr>
+          <p:nvPr>
+            <p:ph type="title"/>
+          </p:nvPr>
+        </p:nvSpPr>
+        <p:spPr/>
+        <p:txBody>
+          <a:bodyPr/>
+          <a:lstStyle/>
+          <a:p>
+            <a:r>
+              <a:rPr lang="en-US"/>
+              <a:t>Click to edit Master title style</a:t>
             </a:r>
           </a:p>
         </p:txBody>
@@ -6574,71 +6527,6 @@
               <a:rPr lang="en-US"/>
               <a:t>Click to edit Master subtitle style</a:t>
             </a:r>
-          </a:p>
-        </p:txBody>
-      </p:sp>
-      <p:sp>
-        <p:nvSpPr>
-          <p:cNvPr id="4" name="Date Placeholder 3"/>
-          <p:cNvSpPr>
-            <a:spLocks noGrp="1"/>
-          </p:cNvSpPr>
-          <p:nvPr>
-            <p:ph type="dt" sz="half" idx="10"/>
-          </p:nvPr>
-        </p:nvSpPr>
-        <p:spPr/>
-        <p:txBody>
-          <a:bodyPr/>
-          <a:lstStyle/>
-          <a:p>
-            <a:fld id="{68F49DD1-DDB5-AB43-B311-7649AD474C82}" type="datetimeFigureOut">
-              <a:rPr lang="en-US" smtClean="0"/>
-              <a:t>10/13/25</a:t>
-            </a:fld>
-            <a:endParaRPr lang="en-US"/>
-          </a:p>
-        </p:txBody>
-      </p:sp>
-      <p:sp>
-        <p:nvSpPr>
-          <p:cNvPr id="5" name="Footer Placeholder 4"/>
-          <p:cNvSpPr>
-            <a:spLocks noGrp="1"/>
-          </p:cNvSpPr>
-          <p:nvPr>
-            <p:ph type="ftr" sz="quarter" idx="11"/>
-          </p:nvPr>
-        </p:nvSpPr>
-        <p:spPr/>
-        <p:txBody>
-          <a:bodyPr/>
-          <a:lstStyle/>
-          <a:p>
-            <a:endParaRPr lang="en-US"/>
-          </a:p>
-        </p:txBody>
-      </p:sp>
-      <p:sp>
-        <p:nvSpPr>
-          <p:cNvPr id="6" name="Slide Number Placeholder 5"/>
-          <p:cNvSpPr>
-            <a:spLocks noGrp="1"/>
-          </p:cNvSpPr>
-          <p:nvPr>
-            <p:ph type="sldNum" sz="quarter" idx="12"/>
-          </p:nvPr>
-        </p:nvSpPr>
-        <p:spPr/>
-        <p:txBody>
-          <a:bodyPr/>
-          <a:lstStyle/>
-          <a:p>
-            <a:fld id="{AEB3D163-D76A-5F4F-A4CE-5FA8F639A976}" type="slidenum">
-              <a:rPr lang="en-US" smtClean="0"/>
-              <a:t>‹#›</a:t>
-            </a:fld>
-            <a:endParaRPr lang="en-US"/>
           </a:p>
         </p:txBody>
       </p:sp>
@@ -8524,7 +8412,7 @@
           <a:p>
             <a:r>
               <a:rPr lang="en-US" dirty="0"/>
-              <a:t>Software Development with LLMs</a:t>
+              <a:t>Responsible Software Development with LLMs</a:t>
             </a:r>
           </a:p>
         </p:txBody>
@@ -8672,7 +8560,7 @@
         <p:spPr>
           <a:xfrm>
             <a:off x="3176925" y="3161813"/>
-            <a:ext cx="8292316" cy="369332"/>
+            <a:ext cx="8292316" cy="923330"/>
           </a:xfrm>
         </p:spPr>
         <p:txBody>
@@ -8685,14 +8573,12 @@
               </a:spcBef>
             </a:pPr>
             <a:r>
-              <a:rPr lang="en-US" sz="2000" b="0" i="0" dirty="0">
+              <a:rPr lang="en-US" dirty="0">
                 <a:solidFill>
                   <a:srgbClr val="111111"/>
                 </a:solidFill>
-                <a:effectLst/>
-                <a:latin typeface="+mn-lt"/>
               </a:rPr>
-              <a:t>BSSW Tutorial – SC 2025</a:t>
+              <a:t>Better Software for Reproducible Science tutorial @ The International Conference for High-Performance Computing, Networking, Storage, and Analysis (SC25) conference</a:t>
             </a:r>
           </a:p>
         </p:txBody>
@@ -8727,7 +8613,7 @@
               <a:rPr lang="en-US" sz="2000" dirty="0">
                 <a:latin typeface="+mn-lt"/>
               </a:rPr>
-              <a:t>Contributors: Anshu Dubey (ANL), David E. Bernhold (ORNL)	</a:t>
+              <a:t>Contributors: Anshu Dubey (ANL), David E. Bernholdt (ORNL)	</a:t>
             </a:r>
           </a:p>
         </p:txBody>
@@ -14680,7 +14566,7 @@
         </p:nvSpPr>
         <p:spPr>
           <a:xfrm>
-            <a:off x="363096" y="112911"/>
+            <a:off x="363096" y="411282"/>
             <a:ext cx="11372473" cy="914400"/>
           </a:xfrm>
         </p:spPr>
@@ -14713,8 +14599,8 @@
         </p:nvSpPr>
         <p:spPr>
           <a:xfrm>
-            <a:off x="409507" y="570111"/>
-            <a:ext cx="11369809" cy="4926228"/>
+            <a:off x="409507" y="868482"/>
+            <a:ext cx="11369809" cy="4047778"/>
           </a:xfrm>
         </p:spPr>
         <p:txBody>
@@ -14767,35 +14653,26 @@
               <a:t>The requested citation the overall tutorial is: </a:t>
             </a:r>
             <a:r>
-              <a:rPr lang="en-US" sz="1600" b="0" i="0" dirty="0">
-                <a:solidFill>
-                  <a:srgbClr val="111111"/>
-                </a:solidFill>
-                <a:effectLst/>
-                <a:latin typeface="+mn-lt"/>
+              <a:rPr lang="en-US" sz="1600" dirty="0"/>
+              <a:t>David E. Bernholdt and Anshu Dubey, Better Software for Reproducible Science tutorial, in The International Conference for High-Performance Computing, Networking, Storage, and Analysis (SC25), St. Louis, Missouri, 2025. DOI: </a:t>
+            </a:r>
+            <a:r>
+              <a:rPr lang="en-US" sz="1600" dirty="0">
+                <a:hlinkClick r:id="rId4"/>
               </a:rPr>
-              <a:t>Anshu Dubey, David E. </a:t>
-            </a:r>
-            <a:r>
-              <a:rPr lang="en-US" sz="1600" b="0" i="0" dirty="0" err="1">
-                <a:solidFill>
-                  <a:srgbClr val="111111"/>
-                </a:solidFill>
-                <a:effectLst/>
-                <a:latin typeface="+mn-lt"/>
-              </a:rPr>
-              <a:t>Bernholdt</a:t>
-            </a:r>
-            <a:r>
-              <a:rPr lang="en-US" sz="1600" b="0" i="0" dirty="0">
-                <a:solidFill>
-                  <a:srgbClr val="111111"/>
-                </a:solidFill>
-                <a:effectLst/>
-                <a:latin typeface="+mn-lt"/>
-              </a:rPr>
-              <a:t>, </a:t>
-            </a:r>
+              <a:t>10.6084/m9.figshare.30394186</a:t>
+            </a:r>
+            <a:r>
+              <a:rPr lang="en-US" sz="1600" dirty="0"/>
+              <a:t>.</a:t>
+            </a:r>
+            <a:endParaRPr lang="en-US" sz="1600" b="0" i="0" dirty="0">
+              <a:solidFill>
+                <a:srgbClr val="111111"/>
+              </a:solidFill>
+              <a:effectLst/>
+              <a:latin typeface="+mn-lt"/>
+            </a:endParaRPr>
           </a:p>
           <a:p>
             <a:pPr>
@@ -14850,13 +14727,20 @@
             </a:pPr>
             <a:r>
               <a:rPr lang="en-US" sz="1400" dirty="0"/>
-              <a:t>This work was supported by the U.S. Department of Energy Office of Science, Office of Advanced Scientific Computing Research (ASCR), and by the Exascale Computing Project (17-SC-20-SC), a collaborative effort of the U.S. Department of Energy Office of Science and the National Nuclear Security Administration</a:t>
-            </a:r>
-            <a:r>
-              <a:rPr lang="en-US" sz="1400" i="1" dirty="0"/>
+              <a:t>This work was supported by the U.S. Department of Energy, Office of Science, Office of Advanced Scientific Computing Research, Next-Generation Scientific Software Technologies (NGSST) and Scientific Discovery through Advanced Computing (</a:t>
+            </a:r>
+            <a:r>
+              <a:rPr lang="en-US" sz="1400" dirty="0" err="1"/>
+              <a:t>SciDAC</a:t>
+            </a:r>
+            <a:r>
+              <a:rPr lang="en-US" sz="1400"/>
+              <a:t>) programs</a:t>
+            </a:r>
+            <a:r>
+              <a:rPr lang="en-US" sz="1400" dirty="0"/>
               <a:t>.</a:t>
             </a:r>
-            <a:endParaRPr lang="en-US" sz="1400" dirty="0"/>
           </a:p>
           <a:p>
             <a:pPr>
@@ -14866,7 +14750,44 @@
             </a:pPr>
             <a:r>
               <a:rPr lang="en-US" sz="1400" dirty="0"/>
+              <a:t>This work was supported by the U.S. Department of Energy Office of Science, Office of Advanced Scientific Computing Research (ASCR), and by the Exascale Computing Project (17-SC-20-SC), a collaborative effort of the U.S. Department of Energy Office of Science and the National Nuclear Security Administration</a:t>
+            </a:r>
+            <a:r>
+              <a:rPr lang="en-US" sz="1400" i="1" dirty="0"/>
+              <a:t>.</a:t>
+            </a:r>
+          </a:p>
+          <a:p>
+            <a:pPr>
+              <a:spcBef>
+                <a:spcPts val="400"/>
+              </a:spcBef>
+            </a:pPr>
+            <a:r>
+              <a:rPr lang="en-US" sz="1400" dirty="0"/>
               <a:t>This work was performed in part at the Argonne National Laboratory, which is managed by UChicago Argonne, LLC for the U.S. Department of Energy under Contract No. DE-AC02-06CH11357.</a:t>
+            </a:r>
+          </a:p>
+          <a:p>
+            <a:pPr>
+              <a:spcBef>
+                <a:spcPts val="400"/>
+              </a:spcBef>
+            </a:pPr>
+            <a:r>
+              <a:rPr lang="en-US" sz="1400" dirty="0"/>
+              <a:t>This work was performed in part at the Lawrence Livermore National Laboratory, which is managed by Lawrence Livermore National Security, LLC for the U.S. Department of Energy under Contract No. DE-AC52-07NA27344.</a:t>
+            </a:r>
+          </a:p>
+          <a:p>
+            <a:pPr>
+              <a:spcBef>
+                <a:spcPts val="400"/>
+              </a:spcBef>
+            </a:pPr>
+            <a:r>
+              <a:rPr lang="en-US" sz="1400" dirty="0"/>
+              <a:t>This work was performed in part at the Los Alamos National Laboratory, which is managed by Triad National Security, LLC for the U.S. Department of Energy under Contract No.89233218CNA000001</a:t>
             </a:r>
           </a:p>
           <a:p>
@@ -14908,7 +14829,7 @@
           <p:nvPr/>
         </p:nvPicPr>
         <p:blipFill>
-          <a:blip r:embed="rId4">
+          <a:blip r:embed="rId5">
             <a:extLst>
               <a:ext uri="{28A0092B-C50C-407E-A947-70E740481C1C}">
                 <a14:useLocalDpi xmlns:a14="http://schemas.microsoft.com/office/drawing/2010/main" val="0"/>
@@ -14943,7 +14864,7 @@
     </p:spTree>
     <p:extLst>
       <p:ext uri="{BB962C8B-B14F-4D97-AF65-F5344CB8AC3E}">
-        <p14:creationId xmlns:p14="http://schemas.microsoft.com/office/powerpoint/2010/main" val="978726433"/>
+        <p14:creationId xmlns:p14="http://schemas.microsoft.com/office/powerpoint/2010/main" val="3100616290"/>
       </p:ext>
     </p:extLst>
   </p:cSld>
@@ -19840,7 +19761,7 @@
                   <a:schemeClr val="bg1"/>
                 </a:solidFill>
               </a:rPr>
-              <a:t>In the handout we had provided a tutorial for </a:t>
+              <a:t>In the hands-on info, we had provided a tutorial for </a:t>
             </a:r>
             <a:r>
               <a:rPr lang="en-US" sz="2000" dirty="0" err="1">
@@ -20577,7 +20498,7 @@
           <a:p>
             <a:r>
               <a:rPr lang="en-US" dirty="0"/>
-              <a:t>Advanced Topic -- Research Software Challenges in Design and Verification</a:t>
+              <a:t>Advanced Topic – Research Software Challenges in Design and Verification</a:t>
             </a:r>
           </a:p>
         </p:txBody>
@@ -23034,7 +22955,7 @@
           <a:noFill/>
           <a:extLst>
             <a:ext uri="{909E8E84-426E-40dd-AFC4-6F175D3DCCD1}">
-              <a14:hiddenFill xmlns:a14="http://schemas.microsoft.com/office/drawing/2010/main" xmlns="">
+              <a14:hiddenFill xmlns="" xmlns:a14="http://schemas.microsoft.com/office/drawing/2010/main">
                 <a:solidFill>
                   <a:srgbClr val="FFFFFF"/>
                 </a:solidFill>
@@ -23322,7 +23243,17 @@
           <a:p>
             <a:r>
               <a:rPr lang="en-US" dirty="0"/>
-              <a:t>Adaptive mesh refinement =&gt; divide domain into blocks</a:t>
+              <a:t>Adaptive mesh refinement </a:t>
+            </a:r>
+            <a:r>
+              <a:rPr lang="en-US" dirty="0">
+                <a:sym typeface="Wingdings" panose="05000000000000000000" pitchFamily="2" charset="2"/>
+              </a:rPr>
+              <a:t></a:t>
+            </a:r>
+            <a:r>
+              <a:rPr lang="en-US" dirty="0"/>
+              <a:t> divide domain into blocks</a:t>
             </a:r>
           </a:p>
           <a:p>
@@ -31516,7 +31447,7 @@
           <a:p>
             <a:r>
               <a:rPr lang="en-US" dirty="0"/>
-              <a:t>Exploring design space – Abstractions</a:t>
+              <a:t>Exploring Design Space – Abstractions</a:t>
             </a:r>
           </a:p>
         </p:txBody>
@@ -34351,7 +34282,7 @@
           <a:p>
             <a:r>
               <a:rPr lang="en-US" dirty="0"/>
-              <a:t>Takeaways so far</a:t>
+              <a:t>Takeaways so Far</a:t>
             </a:r>
           </a:p>
         </p:txBody>
@@ -36137,7 +36068,7 @@
           <a:noFill/>
           <a:extLst>
             <a:ext uri="{909E8E84-426E-40dd-AFC4-6F175D3DCCD1}">
-              <a14:hiddenFill xmlns:a14="http://schemas.microsoft.com/office/drawing/2010/main" xmlns="">
+              <a14:hiddenFill xmlns="" xmlns:a14="http://schemas.microsoft.com/office/drawing/2010/main">
                 <a:solidFill>
                   <a:srgbClr val="FFFFFF"/>
                 </a:solidFill>
@@ -38237,7 +38168,7 @@
           <a:p>
             <a:r>
               <a:rPr lang="en-US" dirty="0"/>
-              <a:t>Step  4:  AMR</a:t>
+              <a:t>Step  4 –  AMR</a:t>
             </a:r>
           </a:p>
         </p:txBody>
@@ -38618,7 +38549,7 @@
           <a:p>
             <a:r>
               <a:rPr lang="en-US" dirty="0"/>
-              <a:t>Step  4:  AMR</a:t>
+              <a:t>Step  4 –  AMR</a:t>
             </a:r>
           </a:p>
         </p:txBody>
@@ -38735,7 +38666,7 @@
           <a:p>
             <a:r>
               <a:rPr lang="en-US" dirty="0"/>
-              <a:t>Requirements gathering </a:t>
+              <a:t>Requirements Gathering </a:t>
             </a:r>
           </a:p>
         </p:txBody>
@@ -39219,7 +39150,7 @@
           <a:p>
             <a:r>
               <a:rPr lang="en-US" dirty="0"/>
-              <a:t>Step  4:  AMR</a:t>
+              <a:t>Step  4 –  AMR</a:t>
             </a:r>
           </a:p>
         </p:txBody>
@@ -43039,7 +42970,7 @@
           </a:lstStyle>
           <a:p>
             <a:r>
-              <a:rPr lang="en-US" sz="3200" b="0" dirty="0"/>
+              <a:rPr lang="en-US" dirty="0"/>
               <a:t>New Paradigm in Design Because of Platform Heterogeneity</a:t>
             </a:r>
           </a:p>
@@ -46681,7 +46612,7 @@
           <a:p>
             <a:r>
               <a:rPr lang="en-US" dirty="0"/>
-              <a:t>Mechanisms Needed by the Code : Example Flash-X</a:t>
+              <a:t>Mechanisms Needed by the Code: Example Flash-X</a:t>
             </a:r>
           </a:p>
         </p:txBody>
@@ -49677,31 +49608,6 @@
       </p:pic>
       <p:sp>
         <p:nvSpPr>
-          <p:cNvPr id="6" name="Slide Number Placeholder 5">
-            <a:extLst>
-              <a:ext uri="{FF2B5EF4-FFF2-40B4-BE49-F238E27FC236}">
-                <a16:creationId xmlns:a16="http://schemas.microsoft.com/office/drawing/2014/main" id="{E72CBAB5-5DC5-D47B-89DE-B3702D3D6579}"/>
-              </a:ext>
-            </a:extLst>
-          </p:cNvPr>
-          <p:cNvSpPr>
-            <a:spLocks noGrp="1"/>
-          </p:cNvSpPr>
-          <p:nvPr>
-            <p:ph type="sldNum" sz="quarter" idx="12"/>
-          </p:nvPr>
-        </p:nvSpPr>
-        <p:spPr/>
-        <p:txBody>
-          <a:bodyPr/>
-          <a:lstStyle/>
-          <a:p>
-            <a:endParaRPr lang="en-US" dirty="0"/>
-          </a:p>
-        </p:txBody>
-      </p:sp>
-      <p:sp>
-        <p:nvSpPr>
           <p:cNvPr id="7" name="Rounded Rectangle 6">
             <a:extLst>
               <a:ext uri="{FF2B5EF4-FFF2-40B4-BE49-F238E27FC236}">
@@ -50025,7 +49931,7 @@
           </a:lstStyle>
           <a:p>
             <a:r>
-              <a:rPr lang="en-US" sz="2999" dirty="0"/>
+              <a:rPr lang="en-US" sz="2800" b="1" dirty="0"/>
               <a:t>Mechanisms Needed by the Code </a:t>
             </a:r>
           </a:p>
@@ -50596,7 +50502,7 @@
             </a:ln>
             <a:extLst>
               <a:ext uri="{C572A759-6A51-4108-AA02-DFA0A04FC94B}">
-                <ma14:wrappingTextBoxFlag xmlns="" xmlns:m="http://schemas.openxmlformats.org/officeDocument/2006/math" xmlns:a14="http://schemas.microsoft.com/office/drawing/2010/main" xmlns:ma14="http://schemas.microsoft.com/office/mac/drawingml/2011/main" val="1"/>
+                <ma14:wrappingTextBoxFlag xmlns:ma14="http://schemas.microsoft.com/office/mac/drawingml/2011/main" xmlns:a14="http://schemas.microsoft.com/office/drawing/2010/main" xmlns:m="http://schemas.openxmlformats.org/officeDocument/2006/math" xmlns="" val="1"/>
               </a:ext>
             </a:extLst>
           </p:spPr>
@@ -50689,7 +50595,7 @@
             </a:ln>
             <a:extLst>
               <a:ext uri="{C572A759-6A51-4108-AA02-DFA0A04FC94B}">
-                <ma14:wrappingTextBoxFlag xmlns="" xmlns:m="http://schemas.openxmlformats.org/officeDocument/2006/math" xmlns:a14="http://schemas.microsoft.com/office/drawing/2010/main" xmlns:ma14="http://schemas.microsoft.com/office/mac/drawingml/2011/main" val="1"/>
+                <ma14:wrappingTextBoxFlag xmlns:ma14="http://schemas.microsoft.com/office/mac/drawingml/2011/main" xmlns:a14="http://schemas.microsoft.com/office/drawing/2010/main" xmlns:m="http://schemas.openxmlformats.org/officeDocument/2006/math" xmlns="" val="1"/>
               </a:ext>
             </a:extLst>
           </p:spPr>
@@ -50805,7 +50711,7 @@
             </a:ln>
             <a:extLst>
               <a:ext uri="{C572A759-6A51-4108-AA02-DFA0A04FC94B}">
-                <ma14:wrappingTextBoxFlag xmlns="" xmlns:m="http://schemas.openxmlformats.org/officeDocument/2006/math" xmlns:a14="http://schemas.microsoft.com/office/drawing/2010/main" xmlns:ma14="http://schemas.microsoft.com/office/mac/drawingml/2011/main" val="1"/>
+                <ma14:wrappingTextBoxFlag xmlns:ma14="http://schemas.microsoft.com/office/mac/drawingml/2011/main" xmlns:a14="http://schemas.microsoft.com/office/drawing/2010/main" xmlns:m="http://schemas.openxmlformats.org/officeDocument/2006/math" xmlns="" val="1"/>
               </a:ext>
             </a:extLst>
           </p:spPr>
@@ -50921,7 +50827,7 @@
             </a:ln>
             <a:extLst>
               <a:ext uri="{C572A759-6A51-4108-AA02-DFA0A04FC94B}">
-                <ma14:wrappingTextBoxFlag xmlns="" xmlns:m="http://schemas.openxmlformats.org/officeDocument/2006/math" xmlns:a14="http://schemas.microsoft.com/office/drawing/2010/main" xmlns:ma14="http://schemas.microsoft.com/office/mac/drawingml/2011/main" val="1"/>
+                <ma14:wrappingTextBoxFlag xmlns:ma14="http://schemas.microsoft.com/office/mac/drawingml/2011/main" xmlns:a14="http://schemas.microsoft.com/office/drawing/2010/main" xmlns:m="http://schemas.openxmlformats.org/officeDocument/2006/math" xmlns="" val="1"/>
               </a:ext>
             </a:extLst>
           </p:spPr>
@@ -52808,7 +52714,7 @@
             </a:ln>
             <a:extLst>
               <a:ext uri="{C572A759-6A51-4108-AA02-DFA0A04FC94B}">
-                <ma14:wrappingTextBoxFlag xmlns:ma14="http://schemas.microsoft.com/office/mac/drawingml/2011/main" xmlns:a14="http://schemas.microsoft.com/office/drawing/2010/main" xmlns:m="http://schemas.openxmlformats.org/officeDocument/2006/math" xmlns="" val="1"/>
+                <ma14:wrappingTextBoxFlag xmlns="" xmlns:m="http://schemas.openxmlformats.org/officeDocument/2006/math" xmlns:a14="http://schemas.microsoft.com/office/drawing/2010/main" xmlns:ma14="http://schemas.microsoft.com/office/mac/drawingml/2011/main" val="1"/>
               </a:ext>
             </a:extLst>
           </p:spPr>
@@ -52914,7 +52820,7 @@
         </p:spPr>
         <p:txBody>
           <a:bodyPr vert="horz" lIns="91416" tIns="45708" rIns="91416" bIns="45708" rtlCol="0" anchor="ctr">
-            <a:normAutofit fontScale="85000" lnSpcReduction="10000"/>
+            <a:noAutofit/>
           </a:bodyPr>
           <a:lstStyle>
             <a:lvl1pPr algn="l" defTabSz="914400" rtl="0" eaLnBrk="1" latinLnBrk="0" hangingPunct="1">
@@ -52937,7 +52843,7 @@
           </a:lstStyle>
           <a:p>
             <a:r>
-              <a:rPr lang="en-US" sz="3999" dirty="0"/>
+              <a:rPr lang="en-US" sz="3200" dirty="0"/>
               <a:t>Orthogonal Axes of Challenges and Optimization</a:t>
             </a:r>
           </a:p>
@@ -54503,7 +54409,7 @@
           <a:p>
             <a:r>
               <a:rPr lang="en-US" dirty="0"/>
-              <a:t>Final takeaways</a:t>
+              <a:t>Final Takeaways</a:t>
             </a:r>
           </a:p>
         </p:txBody>
@@ -56760,6 +56666,12 @@
 </file>
 
 <file path=customXml/item1.xml><?xml version="1.0" encoding="utf-8"?>
+<p:properties xmlns:p="http://schemas.microsoft.com/office/2006/metadata/properties" xmlns:xsi="http://www.w3.org/2001/XMLSchema-instance" xmlns:pc="http://schemas.microsoft.com/office/infopath/2007/PartnerControls">
+  <documentManagement/>
+</p:properties>
+</file>
+
+<file path=customXml/item2.xml><?xml version="1.0" encoding="utf-8"?>
 <ct:contentTypeSchema xmlns:ct="http://schemas.microsoft.com/office/2006/metadata/contentType" xmlns:ma="http://schemas.microsoft.com/office/2006/metadata/properties/metaAttributes" ct:_="" ma:_="" ma:contentTypeName="Document" ma:contentTypeID="0x010100565464437F680748A68B85EB6594EA7D" ma:contentTypeVersion="0" ma:contentTypeDescription="Create a new document." ma:contentTypeScope="" ma:versionID="fe3f4dd58d5914c51cfc6deaa8ad845c">
   <xsd:schema xmlns:xsd="http://www.w3.org/2001/XMLSchema" xmlns:p="http://schemas.microsoft.com/office/2006/metadata/properties" targetNamespace="http://schemas.microsoft.com/office/2006/metadata/properties" ma:root="true" ma:fieldsID="4aeb20c0e3442673af7ee10786458764">
     <xsd:element name="properties">
@@ -56808,7 +56720,7 @@
 </ct:contentTypeSchema>
 </file>
 
-<file path=customXml/item2.xml><?xml version="1.0" encoding="utf-8"?>
+<file path=customXml/item3.xml><?xml version="1.0" encoding="utf-8"?>
 <?mso-contentType ?>
 <FormTemplates xmlns="http://schemas.microsoft.com/sharepoint/v3/contenttype/forms">
   <Display>DocumentLibraryForm</Display>
@@ -56817,13 +56729,22 @@
 </FormTemplates>
 </file>
 
-<file path=customXml/item3.xml><?xml version="1.0" encoding="utf-8"?>
-<p:properties xmlns:p="http://schemas.microsoft.com/office/2006/metadata/properties" xmlns:xsi="http://www.w3.org/2001/XMLSchema-instance" xmlns:pc="http://schemas.microsoft.com/office/infopath/2007/PartnerControls">
-  <documentManagement/>
-</p:properties>
+<file path=customXml/itemProps1.xml><?xml version="1.0" encoding="utf-8"?>
+<ds:datastoreItem xmlns:ds="http://schemas.openxmlformats.org/officeDocument/2006/customXml" ds:itemID="{A50EC660-24D0-43A0-AE5E-E274115E726B}">
+  <ds:schemaRefs>
+    <ds:schemaRef ds:uri="http://purl.org/dc/elements/1.1/"/>
+    <ds:schemaRef ds:uri="http://schemas.microsoft.com/office/2006/metadata/properties"/>
+    <ds:schemaRef ds:uri="http://purl.org/dc/terms/"/>
+    <ds:schemaRef ds:uri="http://schemas.openxmlformats.org/package/2006/metadata/core-properties"/>
+    <ds:schemaRef ds:uri="http://schemas.microsoft.com/office/2006/documentManagement/types"/>
+    <ds:schemaRef ds:uri="http://www.w3.org/XML/1998/namespace"/>
+    <ds:schemaRef ds:uri="http://purl.org/dc/dcmitype/"/>
+    <ds:schemaRef ds:uri="http://schemas.microsoft.com/office/infopath/2007/PartnerControls"/>
+  </ds:schemaRefs>
+</ds:datastoreItem>
 </file>
 
-<file path=customXml/itemProps1.xml><?xml version="1.0" encoding="utf-8"?>
+<file path=customXml/itemProps2.xml><?xml version="1.0" encoding="utf-8"?>
 <ds:datastoreItem xmlns:ds="http://schemas.openxmlformats.org/officeDocument/2006/customXml" ds:itemID="{E8DB7DEB-074E-4EE8-9B6E-FD277323109C}">
   <ds:schemaRefs>
     <ds:schemaRef ds:uri="http://schemas.microsoft.com/office/2006/metadata/contentType"/>
@@ -56838,25 +56759,10 @@
 </ds:datastoreItem>
 </file>
 
-<file path=customXml/itemProps2.xml><?xml version="1.0" encoding="utf-8"?>
+<file path=customXml/itemProps3.xml><?xml version="1.0" encoding="utf-8"?>
 <ds:datastoreItem xmlns:ds="http://schemas.openxmlformats.org/officeDocument/2006/customXml" ds:itemID="{19E20559-B232-4371-8690-E3D8007EDB82}">
   <ds:schemaRefs>
     <ds:schemaRef ds:uri="http://schemas.microsoft.com/sharepoint/v3/contenttype/forms"/>
   </ds:schemaRefs>
 </ds:datastoreItem>
-</file>
-
-<file path=customXml/itemProps3.xml><?xml version="1.0" encoding="utf-8"?>
-<ds:datastoreItem xmlns:ds="http://schemas.openxmlformats.org/officeDocument/2006/customXml" ds:itemID="{A50EC660-24D0-43A0-AE5E-E274115E726B}">
-  <ds:schemaRefs>
-    <ds:schemaRef ds:uri="http://purl.org/dc/elements/1.1/"/>
-    <ds:schemaRef ds:uri="http://schemas.microsoft.com/office/2006/metadata/properties"/>
-    <ds:schemaRef ds:uri="http://purl.org/dc/terms/"/>
-    <ds:schemaRef ds:uri="http://schemas.openxmlformats.org/package/2006/metadata/core-properties"/>
-    <ds:schemaRef ds:uri="http://schemas.microsoft.com/office/2006/documentManagement/types"/>
-    <ds:schemaRef ds:uri="http://www.w3.org/XML/1998/namespace"/>
-    <ds:schemaRef ds:uri="http://purl.org/dc/dcmitype/"/>
-    <ds:schemaRef ds:uri="http://schemas.microsoft.com/office/infopath/2007/PartnerControls"/>
-  </ds:schemaRefs>
-</ds:datastoreItem>
 </file>
</xml_diff>

<commit_message>
added a slide for steps in code generation
</commit_message>
<xml_diff>
--- a/dev-test-llm.pptx
+++ b/dev-test-llm.pptx
@@ -42,7 +42,7 @@
     <p:sldId id="5687" r:id="rId33"/>
     <p:sldId id="5688" r:id="rId34"/>
     <p:sldId id="5691" r:id="rId35"/>
-    <p:sldId id="5692" r:id="rId36"/>
+    <p:sldId id="5696" r:id="rId36"/>
     <p:sldId id="5576" r:id="rId37"/>
     <p:sldId id="5572" r:id="rId38"/>
     <p:sldId id="5570" r:id="rId39"/>
@@ -334,7 +334,7 @@
           <a:p>
             <a:fld id="{0B842F42-2CE9-4E35-95C1-410DC08A50B1}" type="datetimeFigureOut">
               <a:rPr lang="en-US" smtClean="0"/>
-              <a:t>10/26/2025</a:t>
+              <a:t>11/9/25</a:t>
             </a:fld>
             <a:endParaRPr lang="en-US"/>
           </a:p>
@@ -499,7 +499,7 @@
           <a:p>
             <a:fld id="{6F282904-F315-4730-8D91-37D99E141A6F}" type="datetimeFigureOut">
               <a:rPr lang="en-US" smtClean="0"/>
-              <a:t>10/26/2025</a:t>
+              <a:t>11/9/25</a:t>
             </a:fld>
             <a:endParaRPr lang="en-US"/>
           </a:p>
@@ -20407,40 +20407,673 @@
       </p:grpSpPr>
       <p:sp>
         <p:nvSpPr>
-          <p:cNvPr id="4" name="TextBox 3">
+          <p:cNvPr id="3" name="Title 1">
             <a:extLst>
               <a:ext uri="{FF2B5EF4-FFF2-40B4-BE49-F238E27FC236}">
-                <a16:creationId xmlns:a16="http://schemas.microsoft.com/office/drawing/2014/main" id="{69BDE29E-5BF5-E252-AAFE-8932DB71B782}"/>
+                <a16:creationId xmlns:a16="http://schemas.microsoft.com/office/drawing/2014/main" id="{C36412A1-4DCA-4C2F-0A61-76C9F661084C}"/>
               </a:ext>
             </a:extLst>
           </p:cNvPr>
-          <p:cNvSpPr txBox="1"/>
+          <p:cNvSpPr>
+            <a:spLocks noGrp="1"/>
+          </p:cNvSpPr>
+          <p:nvPr>
+            <p:ph type="title"/>
+          </p:nvPr>
+        </p:nvSpPr>
+        <p:spPr>
+          <a:xfrm>
+            <a:off x="365760" y="411480"/>
+            <a:ext cx="11372473" cy="914400"/>
+          </a:xfrm>
+        </p:spPr>
+        <p:txBody>
+          <a:bodyPr/>
+          <a:lstStyle/>
+          <a:p>
+            <a:r>
+              <a:rPr lang="en-US" dirty="0"/>
+              <a:t>My Steps</a:t>
+            </a:r>
+          </a:p>
+        </p:txBody>
+      </p:sp>
+      <p:sp>
+        <p:nvSpPr>
+          <p:cNvPr id="5" name="Content Placeholder 4">
+            <a:extLst>
+              <a:ext uri="{FF2B5EF4-FFF2-40B4-BE49-F238E27FC236}">
+                <a16:creationId xmlns:a16="http://schemas.microsoft.com/office/drawing/2014/main" id="{3F8F78F7-F963-553A-F559-38CC1BB739FC}"/>
+              </a:ext>
+            </a:extLst>
+          </p:cNvPr>
+          <p:cNvSpPr txBox="1">
+            <a:spLocks/>
+          </p:cNvSpPr>
           <p:nvPr/>
         </p:nvSpPr>
         <p:spPr>
           <a:xfrm>
-            <a:off x="4214191" y="2673510"/>
-            <a:ext cx="2670218" cy="517065"/>
+            <a:off x="6246812" y="1111026"/>
+            <a:ext cx="5317834" cy="5458572"/>
           </a:xfrm>
           <a:prstGeom prst="rect">
             <a:avLst/>
           </a:prstGeom>
-          <a:noFill/>
         </p:spPr>
         <p:txBody>
-          <a:bodyPr wrap="none" lIns="118872" tIns="91440" rIns="118872" bIns="91440" rtlCol="0" anchor="ctr" anchorCtr="0">
-            <a:spAutoFit/>
+          <a:bodyPr>
+            <a:normAutofit lnSpcReduction="10000"/>
           </a:bodyPr>
-          <a:lstStyle/>
-          <a:p>
-            <a:pPr algn="l">
+          <a:lstStyle>
+            <a:lvl1pPr marL="230188" indent="-230188" algn="l" rtl="0" eaLnBrk="1" fontAlgn="base" hangingPunct="1">
               <a:lnSpc>
                 <a:spcPct val="90000"/>
               </a:lnSpc>
+              <a:spcBef>
+                <a:spcPts val="1400"/>
+              </a:spcBef>
+              <a:spcAft>
+                <a:spcPct val="0"/>
+              </a:spcAft>
+              <a:buClr>
+                <a:schemeClr val="tx1"/>
+              </a:buClr>
+              <a:buFont typeface="Arial" charset="0"/>
+              <a:buChar char="•"/>
+              <a:defRPr sz="2400" kern="1200">
+                <a:solidFill>
+                  <a:schemeClr val="tx1"/>
+                </a:solidFill>
+                <a:latin typeface="+mn-lt"/>
+                <a:ea typeface="+mn-ea"/>
+                <a:cs typeface="+mn-cs"/>
+              </a:defRPr>
+            </a:lvl1pPr>
+            <a:lvl2pPr marL="625475" indent="-279400" algn="l" rtl="0" eaLnBrk="1" fontAlgn="base" hangingPunct="1">
+              <a:lnSpc>
+                <a:spcPct val="90000"/>
+              </a:lnSpc>
+              <a:spcBef>
+                <a:spcPts val="800"/>
+              </a:spcBef>
+              <a:spcAft>
+                <a:spcPct val="0"/>
+              </a:spcAft>
+              <a:buClr>
+                <a:schemeClr val="tx1"/>
+              </a:buClr>
+              <a:buFont typeface="Arial" charset="0"/>
+              <a:buChar char="–"/>
+              <a:defRPr sz="2000" kern="1200">
+                <a:solidFill>
+                  <a:schemeClr val="tx1"/>
+                </a:solidFill>
+                <a:latin typeface="+mn-lt"/>
+                <a:ea typeface="+mn-ea"/>
+                <a:cs typeface="+mn-cs"/>
+              </a:defRPr>
+            </a:lvl2pPr>
+            <a:lvl3pPr marL="914400" indent="-230188" algn="l" rtl="0" eaLnBrk="1" fontAlgn="base" hangingPunct="1">
+              <a:lnSpc>
+                <a:spcPct val="90000"/>
+              </a:lnSpc>
+              <a:spcBef>
+                <a:spcPts val="800"/>
+              </a:spcBef>
+              <a:spcAft>
+                <a:spcPct val="0"/>
+              </a:spcAft>
+              <a:buClr>
+                <a:schemeClr val="tx1"/>
+              </a:buClr>
+              <a:buFont typeface="Arial" charset="0"/>
+              <a:buChar char="•"/>
+              <a:defRPr sz="1800" kern="1200">
+                <a:solidFill>
+                  <a:schemeClr val="tx1"/>
+                </a:solidFill>
+                <a:latin typeface="+mn-lt"/>
+                <a:ea typeface="+mn-ea"/>
+                <a:cs typeface="+mn-cs"/>
+              </a:defRPr>
+            </a:lvl3pPr>
+            <a:lvl4pPr marL="1144588" indent="-173038" algn="l" rtl="0" eaLnBrk="1" fontAlgn="base" hangingPunct="1">
+              <a:lnSpc>
+                <a:spcPct val="90000"/>
+              </a:lnSpc>
+              <a:spcBef>
+                <a:spcPts val="800"/>
+              </a:spcBef>
+              <a:spcAft>
+                <a:spcPct val="0"/>
+              </a:spcAft>
+              <a:buClr>
+                <a:schemeClr val="tx1"/>
+              </a:buClr>
+              <a:buFont typeface="Arial" charset="0"/>
+              <a:buChar char="–"/>
+              <a:defRPr sz="1600" kern="1200">
+                <a:solidFill>
+                  <a:schemeClr val="tx1"/>
+                </a:solidFill>
+                <a:latin typeface="+mn-lt"/>
+                <a:ea typeface="+mn-ea"/>
+                <a:cs typeface="+mn-cs"/>
+              </a:defRPr>
+            </a:lvl4pPr>
+            <a:lvl5pPr marL="1482725" indent="-222250" algn="l" rtl="0" eaLnBrk="1" fontAlgn="base" hangingPunct="1">
+              <a:lnSpc>
+                <a:spcPct val="90000"/>
+              </a:lnSpc>
+              <a:spcBef>
+                <a:spcPts val="600"/>
+              </a:spcBef>
+              <a:spcAft>
+                <a:spcPct val="0"/>
+              </a:spcAft>
+              <a:buClr>
+                <a:schemeClr val="tx1"/>
+              </a:buClr>
+              <a:buFont typeface="Arial" charset="0"/>
+              <a:buChar char="»"/>
+              <a:defRPr sz="1600" kern="1200">
+                <a:solidFill>
+                  <a:schemeClr val="tx1"/>
+                </a:solidFill>
+                <a:latin typeface="+mn-lt"/>
+                <a:ea typeface="+mn-ea"/>
+                <a:cs typeface="+mn-cs"/>
+              </a:defRPr>
+            </a:lvl5pPr>
+            <a:lvl6pPr marL="2514600" indent="-228600" algn="l" defTabSz="914400" rtl="0" eaLnBrk="1" latinLnBrk="0" hangingPunct="1">
+              <a:spcBef>
+                <a:spcPct val="20000"/>
+              </a:spcBef>
+              <a:buFont typeface="Arial" pitchFamily="34" charset="0"/>
+              <a:buChar char="•"/>
+              <a:defRPr sz="2000" kern="1200">
+                <a:solidFill>
+                  <a:schemeClr val="tx1"/>
+                </a:solidFill>
+                <a:latin typeface="+mn-lt"/>
+                <a:ea typeface="+mn-ea"/>
+                <a:cs typeface="+mn-cs"/>
+              </a:defRPr>
+            </a:lvl6pPr>
+            <a:lvl7pPr marL="2971800" indent="-228600" algn="l" defTabSz="914400" rtl="0" eaLnBrk="1" latinLnBrk="0" hangingPunct="1">
+              <a:spcBef>
+                <a:spcPct val="20000"/>
+              </a:spcBef>
+              <a:buFont typeface="Arial" pitchFamily="34" charset="0"/>
+              <a:buChar char="•"/>
+              <a:defRPr sz="2000" kern="1200">
+                <a:solidFill>
+                  <a:schemeClr val="tx1"/>
+                </a:solidFill>
+                <a:latin typeface="+mn-lt"/>
+                <a:ea typeface="+mn-ea"/>
+                <a:cs typeface="+mn-cs"/>
+              </a:defRPr>
+            </a:lvl7pPr>
+            <a:lvl8pPr marL="3429000" indent="-228600" algn="l" defTabSz="914400" rtl="0" eaLnBrk="1" latinLnBrk="0" hangingPunct="1">
+              <a:spcBef>
+                <a:spcPct val="20000"/>
+              </a:spcBef>
+              <a:buFont typeface="Arial" pitchFamily="34" charset="0"/>
+              <a:buChar char="•"/>
+              <a:defRPr sz="2000" kern="1200">
+                <a:solidFill>
+                  <a:schemeClr val="tx1"/>
+                </a:solidFill>
+                <a:latin typeface="+mn-lt"/>
+                <a:ea typeface="+mn-ea"/>
+                <a:cs typeface="+mn-cs"/>
+              </a:defRPr>
+            </a:lvl8pPr>
+            <a:lvl9pPr marL="3886200" indent="-228600" algn="l" defTabSz="914400" rtl="0" eaLnBrk="1" latinLnBrk="0" hangingPunct="1">
+              <a:spcBef>
+                <a:spcPct val="20000"/>
+              </a:spcBef>
+              <a:buFont typeface="Arial" pitchFamily="34" charset="0"/>
+              <a:buChar char="•"/>
+              <a:defRPr sz="2000" kern="1200">
+                <a:solidFill>
+                  <a:schemeClr val="tx1"/>
+                </a:solidFill>
+                <a:latin typeface="+mn-lt"/>
+                <a:ea typeface="+mn-ea"/>
+                <a:cs typeface="+mn-cs"/>
+              </a:defRPr>
+            </a:lvl9pPr>
+          </a:lstStyle>
+          <a:p>
+            <a:r>
+              <a:rPr lang="en-US" dirty="0"/>
+              <a:t>Test for mesh generation</a:t>
+            </a:r>
+          </a:p>
+          <a:p>
+            <a:pPr lvl="1"/>
+            <a:r>
+              <a:rPr lang="en-US" dirty="0"/>
+              <a:t>Manual inspection</a:t>
+            </a:r>
+          </a:p>
+          <a:p>
+            <a:pPr lvl="2"/>
+            <a:r>
+              <a:rPr lang="en-US" dirty="0"/>
+              <a:t>You can automate, I have a sample test, you can use my output and use it as baseline</a:t>
+            </a:r>
+          </a:p>
+          <a:p>
+            <a:pPr lvl="2"/>
+            <a:r>
+              <a:rPr lang="en-US" dirty="0"/>
+              <a:t>I can give you the reader for baseline</a:t>
+            </a:r>
+          </a:p>
+          <a:p>
+            <a:r>
+              <a:rPr lang="en-US" dirty="0"/>
+              <a:t>Helper function to get </a:t>
+            </a:r>
+            <a:r>
+              <a:rPr lang="en-US" dirty="0" err="1"/>
+              <a:t>BlockID</a:t>
+            </a:r>
+            <a:r>
+              <a:rPr lang="en-US" dirty="0"/>
+              <a:t> from coordinates</a:t>
+            </a:r>
+          </a:p>
+          <a:p>
+            <a:r>
+              <a:rPr lang="en-US" dirty="0"/>
+              <a:t>Code for creating particles lattice</a:t>
+            </a:r>
+          </a:p>
+          <a:p>
+            <a:r>
+              <a:rPr lang="en-US" dirty="0"/>
+              <a:t>Test for lattice verification</a:t>
+            </a:r>
+          </a:p>
+          <a:p>
+            <a:pPr lvl="1"/>
+            <a:r>
+              <a:rPr lang="en-US" dirty="0"/>
+              <a:t>You can use the same sample and reader</a:t>
+            </a:r>
+          </a:p>
+          <a:p>
+            <a:r>
+              <a:rPr lang="en-US" dirty="0"/>
+              <a:t>Code for making particles move</a:t>
+            </a:r>
+          </a:p>
+          <a:p>
+            <a:pPr lvl="1"/>
+            <a:r>
+              <a:rPr lang="en-US" dirty="0"/>
+              <a:t>Testing for verifying correct block association after the move</a:t>
+            </a:r>
+          </a:p>
+          <a:p>
+            <a:pPr lvl="1"/>
+            <a:endParaRPr lang="en-US" dirty="0"/>
+          </a:p>
+        </p:txBody>
+      </p:sp>
+      <p:sp>
+        <p:nvSpPr>
+          <p:cNvPr id="6" name="Content Placeholder 4">
+            <a:extLst>
+              <a:ext uri="{FF2B5EF4-FFF2-40B4-BE49-F238E27FC236}">
+                <a16:creationId xmlns:a16="http://schemas.microsoft.com/office/drawing/2014/main" id="{515FC2F3-23CD-078A-36FF-BB3C5266581C}"/>
+              </a:ext>
+            </a:extLst>
+          </p:cNvPr>
+          <p:cNvSpPr txBox="1">
+            <a:spLocks/>
+          </p:cNvSpPr>
+          <p:nvPr/>
+        </p:nvSpPr>
+        <p:spPr>
+          <a:xfrm>
+            <a:off x="928978" y="1140348"/>
+            <a:ext cx="5317834" cy="5458572"/>
+          </a:xfrm>
+          <a:prstGeom prst="rect">
+            <a:avLst/>
+          </a:prstGeom>
+        </p:spPr>
+        <p:txBody>
+          <a:bodyPr>
+            <a:normAutofit lnSpcReduction="10000"/>
+          </a:bodyPr>
+          <a:lstStyle>
+            <a:lvl1pPr marL="230188" indent="-230188" algn="l" rtl="0" eaLnBrk="1" fontAlgn="base" hangingPunct="1">
+              <a:lnSpc>
+                <a:spcPct val="90000"/>
+              </a:lnSpc>
+              <a:spcBef>
+                <a:spcPts val="1400"/>
+              </a:spcBef>
+              <a:spcAft>
+                <a:spcPct val="0"/>
+              </a:spcAft>
+              <a:buClr>
+                <a:schemeClr val="tx1"/>
+              </a:buClr>
+              <a:buFont typeface="Arial" charset="0"/>
+              <a:buChar char="•"/>
+              <a:defRPr sz="2400" kern="1200">
+                <a:solidFill>
+                  <a:schemeClr val="tx1"/>
+                </a:solidFill>
+                <a:latin typeface="+mn-lt"/>
+                <a:ea typeface="+mn-ea"/>
+                <a:cs typeface="+mn-cs"/>
+              </a:defRPr>
+            </a:lvl1pPr>
+            <a:lvl2pPr marL="625475" indent="-279400" algn="l" rtl="0" eaLnBrk="1" fontAlgn="base" hangingPunct="1">
+              <a:lnSpc>
+                <a:spcPct val="90000"/>
+              </a:lnSpc>
+              <a:spcBef>
+                <a:spcPts val="800"/>
+              </a:spcBef>
+              <a:spcAft>
+                <a:spcPct val="0"/>
+              </a:spcAft>
+              <a:buClr>
+                <a:schemeClr val="tx1"/>
+              </a:buClr>
+              <a:buFont typeface="Arial" charset="0"/>
+              <a:buChar char="–"/>
+              <a:defRPr sz="2000" kern="1200">
+                <a:solidFill>
+                  <a:schemeClr val="tx1"/>
+                </a:solidFill>
+                <a:latin typeface="+mn-lt"/>
+                <a:ea typeface="+mn-ea"/>
+                <a:cs typeface="+mn-cs"/>
+              </a:defRPr>
+            </a:lvl2pPr>
+            <a:lvl3pPr marL="914400" indent="-230188" algn="l" rtl="0" eaLnBrk="1" fontAlgn="base" hangingPunct="1">
+              <a:lnSpc>
+                <a:spcPct val="90000"/>
+              </a:lnSpc>
+              <a:spcBef>
+                <a:spcPts val="800"/>
+              </a:spcBef>
+              <a:spcAft>
+                <a:spcPct val="0"/>
+              </a:spcAft>
+              <a:buClr>
+                <a:schemeClr val="tx1"/>
+              </a:buClr>
+              <a:buFont typeface="Arial" charset="0"/>
+              <a:buChar char="•"/>
+              <a:defRPr sz="1800" kern="1200">
+                <a:solidFill>
+                  <a:schemeClr val="tx1"/>
+                </a:solidFill>
+                <a:latin typeface="+mn-lt"/>
+                <a:ea typeface="+mn-ea"/>
+                <a:cs typeface="+mn-cs"/>
+              </a:defRPr>
+            </a:lvl3pPr>
+            <a:lvl4pPr marL="1144588" indent="-173038" algn="l" rtl="0" eaLnBrk="1" fontAlgn="base" hangingPunct="1">
+              <a:lnSpc>
+                <a:spcPct val="90000"/>
+              </a:lnSpc>
+              <a:spcBef>
+                <a:spcPts val="800"/>
+              </a:spcBef>
+              <a:spcAft>
+                <a:spcPct val="0"/>
+              </a:spcAft>
+              <a:buClr>
+                <a:schemeClr val="tx1"/>
+              </a:buClr>
+              <a:buFont typeface="Arial" charset="0"/>
+              <a:buChar char="–"/>
+              <a:defRPr sz="1600" kern="1200">
+                <a:solidFill>
+                  <a:schemeClr val="tx1"/>
+                </a:solidFill>
+                <a:latin typeface="+mn-lt"/>
+                <a:ea typeface="+mn-ea"/>
+                <a:cs typeface="+mn-cs"/>
+              </a:defRPr>
+            </a:lvl4pPr>
+            <a:lvl5pPr marL="1482725" indent="-222250" algn="l" rtl="0" eaLnBrk="1" fontAlgn="base" hangingPunct="1">
+              <a:lnSpc>
+                <a:spcPct val="90000"/>
+              </a:lnSpc>
+              <a:spcBef>
+                <a:spcPts val="600"/>
+              </a:spcBef>
+              <a:spcAft>
+                <a:spcPct val="0"/>
+              </a:spcAft>
+              <a:buClr>
+                <a:schemeClr val="tx1"/>
+              </a:buClr>
+              <a:buFont typeface="Arial" charset="0"/>
+              <a:buChar char="»"/>
+              <a:defRPr sz="1600" kern="1200">
+                <a:solidFill>
+                  <a:schemeClr val="tx1"/>
+                </a:solidFill>
+                <a:latin typeface="+mn-lt"/>
+                <a:ea typeface="+mn-ea"/>
+                <a:cs typeface="+mn-cs"/>
+              </a:defRPr>
+            </a:lvl5pPr>
+            <a:lvl6pPr marL="2514600" indent="-228600" algn="l" defTabSz="914400" rtl="0" eaLnBrk="1" latinLnBrk="0" hangingPunct="1">
+              <a:spcBef>
+                <a:spcPct val="20000"/>
+              </a:spcBef>
+              <a:buFont typeface="Arial" pitchFamily="34" charset="0"/>
+              <a:buChar char="•"/>
+              <a:defRPr sz="2000" kern="1200">
+                <a:solidFill>
+                  <a:schemeClr val="tx1"/>
+                </a:solidFill>
+                <a:latin typeface="+mn-lt"/>
+                <a:ea typeface="+mn-ea"/>
+                <a:cs typeface="+mn-cs"/>
+              </a:defRPr>
+            </a:lvl6pPr>
+            <a:lvl7pPr marL="2971800" indent="-228600" algn="l" defTabSz="914400" rtl="0" eaLnBrk="1" latinLnBrk="0" hangingPunct="1">
+              <a:spcBef>
+                <a:spcPct val="20000"/>
+              </a:spcBef>
+              <a:buFont typeface="Arial" pitchFamily="34" charset="0"/>
+              <a:buChar char="•"/>
+              <a:defRPr sz="2000" kern="1200">
+                <a:solidFill>
+                  <a:schemeClr val="tx1"/>
+                </a:solidFill>
+                <a:latin typeface="+mn-lt"/>
+                <a:ea typeface="+mn-ea"/>
+                <a:cs typeface="+mn-cs"/>
+              </a:defRPr>
+            </a:lvl7pPr>
+            <a:lvl8pPr marL="3429000" indent="-228600" algn="l" defTabSz="914400" rtl="0" eaLnBrk="1" latinLnBrk="0" hangingPunct="1">
+              <a:spcBef>
+                <a:spcPct val="20000"/>
+              </a:spcBef>
+              <a:buFont typeface="Arial" pitchFamily="34" charset="0"/>
+              <a:buChar char="•"/>
+              <a:defRPr sz="2000" kern="1200">
+                <a:solidFill>
+                  <a:schemeClr val="tx1"/>
+                </a:solidFill>
+                <a:latin typeface="+mn-lt"/>
+                <a:ea typeface="+mn-ea"/>
+                <a:cs typeface="+mn-cs"/>
+              </a:defRPr>
+            </a:lvl8pPr>
+            <a:lvl9pPr marL="3886200" indent="-228600" algn="l" defTabSz="914400" rtl="0" eaLnBrk="1" latinLnBrk="0" hangingPunct="1">
+              <a:spcBef>
+                <a:spcPct val="20000"/>
+              </a:spcBef>
+              <a:buFont typeface="Arial" pitchFamily="34" charset="0"/>
+              <a:buChar char="•"/>
+              <a:defRPr sz="2000" kern="1200">
+                <a:solidFill>
+                  <a:schemeClr val="tx1"/>
+                </a:solidFill>
+                <a:latin typeface="+mn-lt"/>
+                <a:ea typeface="+mn-ea"/>
+                <a:cs typeface="+mn-cs"/>
+              </a:defRPr>
+            </a:lvl9pPr>
+          </a:lstStyle>
+          <a:p>
+            <a:r>
+              <a:rPr lang="en-US" dirty="0"/>
+              <a:t>Defined some constants</a:t>
+            </a:r>
+          </a:p>
+          <a:p>
+            <a:pPr lvl="1">
+              <a:spcBef>
+                <a:spcPts val="200"/>
+              </a:spcBef>
             </a:pPr>
             <a:r>
-              <a:rPr lang="en-US" sz="2400" dirty="0"/>
-              <a:t>Switch to terminal</a:t>
+              <a:rPr lang="en-US" sz="2000" dirty="0"/>
+              <a:t>LOW =1 1 lower end</a:t>
+            </a:r>
+          </a:p>
+          <a:p>
+            <a:pPr lvl="1">
+              <a:spcBef>
+                <a:spcPts val="200"/>
+              </a:spcBef>
+            </a:pPr>
+            <a:r>
+              <a:rPr lang="en-US" sz="2000" dirty="0"/>
+              <a:t>HIGH = 2 upper end</a:t>
+            </a:r>
+          </a:p>
+          <a:p>
+            <a:pPr lvl="1">
+              <a:spcBef>
+                <a:spcPts val="200"/>
+              </a:spcBef>
+            </a:pPr>
+            <a:r>
+              <a:rPr lang="en-US" sz="2000" dirty="0"/>
+              <a:t>INTERIOR = 3 </a:t>
+            </a:r>
+          </a:p>
+          <a:p>
+            <a:pPr lvl="1">
+              <a:spcBef>
+                <a:spcPts val="200"/>
+              </a:spcBef>
+            </a:pPr>
+            <a:r>
+              <a:rPr lang="en-US" sz="2000" dirty="0"/>
+              <a:t>MDIM =  3 the maximum possible dimensionality</a:t>
+            </a:r>
+          </a:p>
+          <a:p>
+            <a:pPr lvl="1">
+              <a:spcBef>
+                <a:spcPts val="200"/>
+              </a:spcBef>
+            </a:pPr>
+            <a:r>
+              <a:rPr lang="en-US" sz="2000" dirty="0"/>
+              <a:t>IAXIS  =1  x axis</a:t>
+            </a:r>
+          </a:p>
+          <a:p>
+            <a:pPr lvl="1">
+              <a:spcBef>
+                <a:spcPts val="200"/>
+              </a:spcBef>
+            </a:pPr>
+            <a:r>
+              <a:rPr lang="en-US" sz="2000" dirty="0"/>
+              <a:t>JAXIS  =2  y axis</a:t>
+            </a:r>
+          </a:p>
+          <a:p>
+            <a:pPr lvl="1">
+              <a:spcBef>
+                <a:spcPts val="200"/>
+              </a:spcBef>
+            </a:pPr>
+            <a:r>
+              <a:rPr lang="en-US" sz="2000" dirty="0"/>
+              <a:t>KAXIS  =3  z  axis</a:t>
+            </a:r>
+          </a:p>
+          <a:p>
+            <a:pPr lvl="1">
+              <a:spcBef>
+                <a:spcPts val="200"/>
+              </a:spcBef>
+            </a:pPr>
+            <a:r>
+              <a:rPr lang="en-US" sz="2000" dirty="0"/>
+              <a:t>BLOCK = 4 identity of the block</a:t>
+            </a:r>
+          </a:p>
+          <a:p>
+            <a:pPr lvl="1">
+              <a:spcBef>
+                <a:spcPts val="200"/>
+              </a:spcBef>
+            </a:pPr>
+            <a:r>
+              <a:rPr lang="en-US" sz="2000" dirty="0"/>
+              <a:t>PERIODIC =10 -- periodic boundary condition</a:t>
+            </a:r>
+          </a:p>
+          <a:p>
+            <a:pPr lvl="1">
+              <a:spcBef>
+                <a:spcPts val="200"/>
+              </a:spcBef>
+            </a:pPr>
+            <a:r>
+              <a:rPr lang="en-US" sz="2000" dirty="0"/>
+              <a:t>REFLECTIVE  = 11 -- reflective boundary condition</a:t>
+            </a:r>
+          </a:p>
+          <a:p>
+            <a:pPr lvl="1">
+              <a:spcBef>
+                <a:spcPts val="200"/>
+              </a:spcBef>
+            </a:pPr>
+            <a:r>
+              <a:rPr lang="en-US" sz="2000" dirty="0"/>
+              <a:t>OUTFLOW  = 12  outflow boundary condition</a:t>
+            </a:r>
+            <a:endParaRPr lang="en-US" dirty="0"/>
+          </a:p>
+          <a:p>
+            <a:r>
+              <a:rPr lang="en-US" dirty="0"/>
+              <a:t>Code for mesh generation</a:t>
+            </a:r>
+          </a:p>
+          <a:p>
+            <a:pPr lvl="1"/>
+            <a:r>
+              <a:rPr lang="en-US" dirty="0"/>
+              <a:t>I opted to prompt user for mesh specs</a:t>
             </a:r>
           </a:p>
         </p:txBody>
@@ -20448,7 +21081,7 @@
     </p:spTree>
     <p:extLst>
       <p:ext uri="{BB962C8B-B14F-4D97-AF65-F5344CB8AC3E}">
-        <p14:creationId xmlns:p14="http://schemas.microsoft.com/office/powerpoint/2010/main" val="327465625"/>
+        <p14:creationId xmlns:p14="http://schemas.microsoft.com/office/powerpoint/2010/main" val="3251377738"/>
       </p:ext>
     </p:extLst>
   </p:cSld>
@@ -22955,7 +23588,7 @@
           <a:noFill/>
           <a:extLst>
             <a:ext uri="{909E8E84-426E-40dd-AFC4-6F175D3DCCD1}">
-              <a14:hiddenFill xmlns="" xmlns:a14="http://schemas.microsoft.com/office/drawing/2010/main">
+              <a14:hiddenFill xmlns:a14="http://schemas.microsoft.com/office/drawing/2010/main" xmlns="">
                 <a:solidFill>
                   <a:srgbClr val="FFFFFF"/>
                 </a:solidFill>
@@ -23315,7 +23948,7 @@
             <a:pPr lvl="1"/>
             <a:r>
               <a:rPr lang="en-US" dirty="0"/>
-              <a:t>Halo cells are fine-coarse boundaries need EOS after interpolation</a:t>
+              <a:t>Halo cells at fine-coarse boundaries need EOS after interpolation</a:t>
             </a:r>
           </a:p>
           <a:p>
@@ -36068,7 +36701,7 @@
           <a:noFill/>
           <a:extLst>
             <a:ext uri="{909E8E84-426E-40dd-AFC4-6F175D3DCCD1}">
-              <a14:hiddenFill xmlns="" xmlns:a14="http://schemas.microsoft.com/office/drawing/2010/main">
+              <a14:hiddenFill xmlns:a14="http://schemas.microsoft.com/office/drawing/2010/main" xmlns="">
                 <a:solidFill>
                   <a:srgbClr val="FFFFFF"/>
                 </a:solidFill>
@@ -50502,7 +51135,7 @@
             </a:ln>
             <a:extLst>
               <a:ext uri="{C572A759-6A51-4108-AA02-DFA0A04FC94B}">
-                <ma14:wrappingTextBoxFlag xmlns:ma14="http://schemas.microsoft.com/office/mac/drawingml/2011/main" xmlns:a14="http://schemas.microsoft.com/office/drawing/2010/main" xmlns:m="http://schemas.openxmlformats.org/officeDocument/2006/math" xmlns="" val="1"/>
+                <ma14:wrappingTextBoxFlag xmlns="" xmlns:m="http://schemas.openxmlformats.org/officeDocument/2006/math" xmlns:a14="http://schemas.microsoft.com/office/drawing/2010/main" xmlns:ma14="http://schemas.microsoft.com/office/mac/drawingml/2011/main" val="1"/>
               </a:ext>
             </a:extLst>
           </p:spPr>
@@ -50595,7 +51228,7 @@
             </a:ln>
             <a:extLst>
               <a:ext uri="{C572A759-6A51-4108-AA02-DFA0A04FC94B}">
-                <ma14:wrappingTextBoxFlag xmlns:ma14="http://schemas.microsoft.com/office/mac/drawingml/2011/main" xmlns:a14="http://schemas.microsoft.com/office/drawing/2010/main" xmlns:m="http://schemas.openxmlformats.org/officeDocument/2006/math" xmlns="" val="1"/>
+                <ma14:wrappingTextBoxFlag xmlns="" xmlns:m="http://schemas.openxmlformats.org/officeDocument/2006/math" xmlns:a14="http://schemas.microsoft.com/office/drawing/2010/main" xmlns:ma14="http://schemas.microsoft.com/office/mac/drawingml/2011/main" val="1"/>
               </a:ext>
             </a:extLst>
           </p:spPr>
@@ -50711,7 +51344,7 @@
             </a:ln>
             <a:extLst>
               <a:ext uri="{C572A759-6A51-4108-AA02-DFA0A04FC94B}">
-                <ma14:wrappingTextBoxFlag xmlns:ma14="http://schemas.microsoft.com/office/mac/drawingml/2011/main" xmlns:a14="http://schemas.microsoft.com/office/drawing/2010/main" xmlns:m="http://schemas.openxmlformats.org/officeDocument/2006/math" xmlns="" val="1"/>
+                <ma14:wrappingTextBoxFlag xmlns="" xmlns:m="http://schemas.openxmlformats.org/officeDocument/2006/math" xmlns:a14="http://schemas.microsoft.com/office/drawing/2010/main" xmlns:ma14="http://schemas.microsoft.com/office/mac/drawingml/2011/main" val="1"/>
               </a:ext>
             </a:extLst>
           </p:spPr>
@@ -50827,7 +51460,7 @@
             </a:ln>
             <a:extLst>
               <a:ext uri="{C572A759-6A51-4108-AA02-DFA0A04FC94B}">
-                <ma14:wrappingTextBoxFlag xmlns:ma14="http://schemas.microsoft.com/office/mac/drawingml/2011/main" xmlns:a14="http://schemas.microsoft.com/office/drawing/2010/main" xmlns:m="http://schemas.openxmlformats.org/officeDocument/2006/math" xmlns="" val="1"/>
+                <ma14:wrappingTextBoxFlag xmlns="" xmlns:m="http://schemas.openxmlformats.org/officeDocument/2006/math" xmlns:a14="http://schemas.microsoft.com/office/drawing/2010/main" xmlns:ma14="http://schemas.microsoft.com/office/mac/drawingml/2011/main" val="1"/>
               </a:ext>
             </a:extLst>
           </p:spPr>
@@ -52714,7 +53347,7 @@
             </a:ln>
             <a:extLst>
               <a:ext uri="{C572A759-6A51-4108-AA02-DFA0A04FC94B}">
-                <ma14:wrappingTextBoxFlag xmlns="" xmlns:m="http://schemas.openxmlformats.org/officeDocument/2006/math" xmlns:a14="http://schemas.microsoft.com/office/drawing/2010/main" xmlns:ma14="http://schemas.microsoft.com/office/mac/drawingml/2011/main" val="1"/>
+                <ma14:wrappingTextBoxFlag xmlns:ma14="http://schemas.microsoft.com/office/mac/drawingml/2011/main" xmlns:a14="http://schemas.microsoft.com/office/drawing/2010/main" xmlns:m="http://schemas.openxmlformats.org/officeDocument/2006/math" xmlns="" val="1"/>
               </a:ext>
             </a:extLst>
           </p:spPr>

</xml_diff>